<commit_message>
Update desktop files: add strategy folders, reorganize Tore Div, update MRB simulation
- Add AKER, FMC, ONESUBSEA, SUBSEA7 strategy folders with sales/contact tracking
- Add OEE and Økonomi modules
- Add MRB markdown versions alongside HTML files
- Add MRB_Simulation changelog and README
- Add SDRL sample files
- Add Møte Fearnley folder
- Add GOTO Market presentation for Innovasjon Norge
- Reorganize Tore Div into numbered categories (01-10)
- Update MRB Simulation HTML files and remove obsolete entries
- Update KDA Strategy contact log and sales report
- Update Investor Pitch Deck
- Add expense report and receipts (Feb-Mar 2026)
- Restore .gitignore

Co-Authored-By: Claude Opus 4.6 <noreply@anthropic.com>
</commit_message>
<xml_diff>
--- a/Aurelian/Aurelian Manufacturing/Aurelian_VDR/07_Presentations/7.1_Investor_Pitch_Deck/07_Investor_Pitch_Deck_Seed_V4.pptx
+++ b/Aurelian/Aurelian Manufacturing/Aurelian_VDR/07_Presentations/7.1_Investor_Pitch_Deck/07_Investor_Pitch_Deck_Seed_V4.pptx
@@ -142,6 +142,22 @@
 <file path=ppt/changesInfos/changesInfo1.xml><?xml version="1.0" encoding="utf-8"?>
 <pc:chgInfo xmlns:a="http://schemas.openxmlformats.org/drawingml/2006/main" xmlns:r="http://schemas.openxmlformats.org/officeDocument/2006/relationships" xmlns:ac="http://schemas.microsoft.com/office/drawing/2013/main/command" xmlns:pc="http://schemas.microsoft.com/office/powerpoint/2013/main/command">
   <pc:docChgLst>
+    <pc:chgData name="Tore Ausland" userId="93c6fb57-3177-4437-8d3b-08c4a3bd5063" providerId="ADAL" clId="{C7003D35-0069-4681-A939-A1D689C68C91}"/>
+    <pc:docChg chg="modSld">
+      <pc:chgData name="Tore Ausland" userId="93c6fb57-3177-4437-8d3b-08c4a3bd5063" providerId="ADAL" clId="{C7003D35-0069-4681-A939-A1D689C68C91}" dt="2026-03-02T19:43:59.065" v="0" actId="729"/>
+      <pc:docMkLst>
+        <pc:docMk/>
+      </pc:docMkLst>
+      <pc:sldChg chg="mod modShow">
+        <pc:chgData name="Tore Ausland" userId="93c6fb57-3177-4437-8d3b-08c4a3bd5063" providerId="ADAL" clId="{C7003D35-0069-4681-A939-A1D689C68C91}" dt="2026-03-02T19:43:59.065" v="0" actId="729"/>
+        <pc:sldMkLst>
+          <pc:docMk/>
+          <pc:sldMk cId="0" sldId="268"/>
+        </pc:sldMkLst>
+      </pc:sldChg>
+    </pc:docChg>
+  </pc:docChgLst>
+  <pc:docChgLst>
     <pc:chgData name="Tore Ausland" userId="aba57685-d7d9-45f9-a74d-a4b3d109653f" providerId="ADAL" clId="{C7003D35-0069-4681-A939-A1D689C68C91}"/>
     <pc:docChg chg="modSld">
       <pc:chgData name="Tore Ausland" userId="aba57685-d7d9-45f9-a74d-a4b3d109653f" providerId="ADAL" clId="{C7003D35-0069-4681-A939-A1D689C68C91}" dt="2026-02-16T10:12:13.742" v="5" actId="20577"/>
@@ -249,7 +265,7 @@
           </a:lstStyle>
           <a:p>
             <a:fld id="{4053D6E3-9B20-47CE-AB5C-7CAAB06076AE}" type="datetimeFigureOut">
-              <a:t>16.02.2026</a:t>
+              <a:t>02.03.2026</a:t>
             </a:fld>
             <a:endParaRPr lang="en-US"/>
           </a:p>
@@ -825,7 +841,7 @@
           <a:p>
             <a:fld id="{5BCAD085-E8A6-8845-BD4E-CB4CCA059FC4}" type="datetimeFigureOut">
               <a:rPr lang="en-US" smtClean="0"/>
-              <a:t>2/16/2026</a:t>
+              <a:t>3/2/2026</a:t>
             </a:fld>
             <a:endParaRPr lang="en-US"/>
           </a:p>
@@ -993,7 +1009,7 @@
           <a:p>
             <a:fld id="{5BCAD085-E8A6-8845-BD4E-CB4CCA059FC4}" type="datetimeFigureOut">
               <a:rPr lang="en-US" smtClean="0"/>
-              <a:t>2/16/2026</a:t>
+              <a:t>3/2/2026</a:t>
             </a:fld>
             <a:endParaRPr lang="en-US"/>
           </a:p>
@@ -1171,7 +1187,7 @@
           <a:p>
             <a:fld id="{5BCAD085-E8A6-8845-BD4E-CB4CCA059FC4}" type="datetimeFigureOut">
               <a:rPr lang="en-US" smtClean="0"/>
-              <a:t>2/16/2026</a:t>
+              <a:t>3/2/2026</a:t>
             </a:fld>
             <a:endParaRPr lang="en-US"/>
           </a:p>
@@ -1339,7 +1355,7 @@
           <a:p>
             <a:fld id="{5BCAD085-E8A6-8845-BD4E-CB4CCA059FC4}" type="datetimeFigureOut">
               <a:rPr lang="en-US" smtClean="0"/>
-              <a:t>2/16/2026</a:t>
+              <a:t>3/2/2026</a:t>
             </a:fld>
             <a:endParaRPr lang="en-US"/>
           </a:p>
@@ -1584,7 +1600,7 @@
           <a:p>
             <a:fld id="{5BCAD085-E8A6-8845-BD4E-CB4CCA059FC4}" type="datetimeFigureOut">
               <a:rPr lang="en-US" smtClean="0"/>
-              <a:t>2/16/2026</a:t>
+              <a:t>3/2/2026</a:t>
             </a:fld>
             <a:endParaRPr lang="en-US"/>
           </a:p>
@@ -1869,7 +1885,7 @@
           <a:p>
             <a:fld id="{5BCAD085-E8A6-8845-BD4E-CB4CCA059FC4}" type="datetimeFigureOut">
               <a:rPr lang="en-US" smtClean="0"/>
-              <a:t>2/16/2026</a:t>
+              <a:t>3/2/2026</a:t>
             </a:fld>
             <a:endParaRPr lang="en-US"/>
           </a:p>
@@ -2288,7 +2304,7 @@
           <a:p>
             <a:fld id="{5BCAD085-E8A6-8845-BD4E-CB4CCA059FC4}" type="datetimeFigureOut">
               <a:rPr lang="en-US" smtClean="0"/>
-              <a:t>2/16/2026</a:t>
+              <a:t>3/2/2026</a:t>
             </a:fld>
             <a:endParaRPr lang="en-US"/>
           </a:p>
@@ -2405,7 +2421,7 @@
           <a:p>
             <a:fld id="{5BCAD085-E8A6-8845-BD4E-CB4CCA059FC4}" type="datetimeFigureOut">
               <a:rPr lang="en-US" smtClean="0"/>
-              <a:t>2/16/2026</a:t>
+              <a:t>3/2/2026</a:t>
             </a:fld>
             <a:endParaRPr lang="en-US"/>
           </a:p>
@@ -2500,7 +2516,7 @@
           <a:p>
             <a:fld id="{5BCAD085-E8A6-8845-BD4E-CB4CCA059FC4}" type="datetimeFigureOut">
               <a:rPr lang="en-US" smtClean="0"/>
-              <a:t>2/16/2026</a:t>
+              <a:t>3/2/2026</a:t>
             </a:fld>
             <a:endParaRPr lang="en-US"/>
           </a:p>
@@ -2775,7 +2791,7 @@
           <a:p>
             <a:fld id="{5BCAD085-E8A6-8845-BD4E-CB4CCA059FC4}" type="datetimeFigureOut">
               <a:rPr lang="en-US" smtClean="0"/>
-              <a:t>2/16/2026</a:t>
+              <a:t>3/2/2026</a:t>
             </a:fld>
             <a:endParaRPr lang="en-US"/>
           </a:p>
@@ -3027,7 +3043,7 @@
           <a:p>
             <a:fld id="{5BCAD085-E8A6-8845-BD4E-CB4CCA059FC4}" type="datetimeFigureOut">
               <a:rPr lang="en-US" smtClean="0"/>
-              <a:t>2/16/2026</a:t>
+              <a:t>3/2/2026</a:t>
             </a:fld>
             <a:endParaRPr lang="en-US"/>
           </a:p>
@@ -3238,7 +3254,7 @@
           <a:p>
             <a:fld id="{5BCAD085-E8A6-8845-BD4E-CB4CCA059FC4}" type="datetimeFigureOut">
               <a:rPr lang="en-US" smtClean="0"/>
-              <a:t>2/16/2026</a:t>
+              <a:t>3/2/2026</a:t>
             </a:fld>
             <a:endParaRPr lang="en-US"/>
           </a:p>
@@ -5101,7 +5117,7 @@
           <a:noFill/>
         </p:spPr>
         <p:txBody>
-          <a:bodyPr wrap="square" tIns="0" bIns="0" lIns="0" rIns="0">
+          <a:bodyPr wrap="square" lIns="0" tIns="0" rIns="0" bIns="0">
             <a:spAutoFit/>
           </a:bodyPr>
           <a:lstStyle/>
@@ -5136,7 +5152,7 @@
           <a:noFill/>
         </p:spPr>
         <p:txBody>
-          <a:bodyPr wrap="square" tIns="0" bIns="0" lIns="0" rIns="0">
+          <a:bodyPr wrap="square" lIns="0" tIns="0" rIns="0" bIns="0">
             <a:spAutoFit/>
           </a:bodyPr>
           <a:lstStyle/>
@@ -5196,6 +5212,7 @@
           <a:lstStyle/>
           <a:p>
             <a:pPr algn="ctr"/>
+            <a:endParaRPr/>
           </a:p>
         </p:txBody>
       </p:sp>
@@ -5239,6 +5256,7 @@
           <a:lstStyle/>
           <a:p>
             <a:pPr algn="ctr"/>
+            <a:endParaRPr/>
           </a:p>
         </p:txBody>
       </p:sp>
@@ -5259,7 +5277,7 @@
           <a:noFill/>
         </p:spPr>
         <p:txBody>
-          <a:bodyPr wrap="square" tIns="0" bIns="0" lIns="0" rIns="0">
+          <a:bodyPr wrap="square" lIns="0" tIns="0" rIns="0" bIns="0">
             <a:spAutoFit/>
           </a:bodyPr>
           <a:lstStyle/>
@@ -5294,7 +5312,7 @@
           <a:noFill/>
         </p:spPr>
         <p:txBody>
-          <a:bodyPr wrap="square" tIns="0" bIns="0" lIns="0" rIns="0">
+          <a:bodyPr wrap="square" lIns="0" tIns="0" rIns="0" bIns="0">
             <a:spAutoFit/>
           </a:bodyPr>
           <a:lstStyle/>
@@ -5329,7 +5347,7 @@
           <a:noFill/>
         </p:spPr>
         <p:txBody>
-          <a:bodyPr wrap="square" tIns="0" bIns="0" lIns="0" rIns="0">
+          <a:bodyPr wrap="square" lIns="0" tIns="0" rIns="0" bIns="0">
             <a:spAutoFit/>
           </a:bodyPr>
           <a:lstStyle/>
@@ -5364,7 +5382,7 @@
           <a:noFill/>
         </p:spPr>
         <p:txBody>
-          <a:bodyPr wrap="square" tIns="0" bIns="0" lIns="0" rIns="0">
+          <a:bodyPr wrap="square" lIns="0" tIns="0" rIns="0" bIns="0">
             <a:spAutoFit/>
           </a:bodyPr>
           <a:lstStyle/>
@@ -5424,6 +5442,7 @@
           <a:lstStyle/>
           <a:p>
             <a:pPr algn="ctr"/>
+            <a:endParaRPr/>
           </a:p>
         </p:txBody>
       </p:sp>
@@ -5467,6 +5486,7 @@
           <a:lstStyle/>
           <a:p>
             <a:pPr algn="ctr"/>
+            <a:endParaRPr/>
           </a:p>
         </p:txBody>
       </p:sp>
@@ -5487,7 +5507,7 @@
           <a:noFill/>
         </p:spPr>
         <p:txBody>
-          <a:bodyPr wrap="square" tIns="0" bIns="0" lIns="0" rIns="0">
+          <a:bodyPr wrap="square" lIns="0" tIns="0" rIns="0" bIns="0">
             <a:spAutoFit/>
           </a:bodyPr>
           <a:lstStyle/>
@@ -5522,7 +5542,7 @@
           <a:noFill/>
         </p:spPr>
         <p:txBody>
-          <a:bodyPr wrap="square" tIns="0" bIns="0" lIns="0" rIns="0">
+          <a:bodyPr wrap="square" lIns="0" tIns="0" rIns="0" bIns="0">
             <a:spAutoFit/>
           </a:bodyPr>
           <a:lstStyle/>
@@ -5557,7 +5577,7 @@
           <a:noFill/>
         </p:spPr>
         <p:txBody>
-          <a:bodyPr wrap="square" tIns="0" bIns="0" lIns="0" rIns="0">
+          <a:bodyPr wrap="square" lIns="0" tIns="0" rIns="0" bIns="0">
             <a:spAutoFit/>
           </a:bodyPr>
           <a:lstStyle/>
@@ -5592,7 +5612,7 @@
           <a:noFill/>
         </p:spPr>
         <p:txBody>
-          <a:bodyPr wrap="square" tIns="0" bIns="0" lIns="0" rIns="0">
+          <a:bodyPr wrap="square" lIns="0" tIns="0" rIns="0" bIns="0">
             <a:spAutoFit/>
           </a:bodyPr>
           <a:lstStyle/>
@@ -5652,6 +5672,7 @@
           <a:lstStyle/>
           <a:p>
             <a:pPr algn="ctr"/>
+            <a:endParaRPr/>
           </a:p>
         </p:txBody>
       </p:sp>
@@ -5695,6 +5716,7 @@
           <a:lstStyle/>
           <a:p>
             <a:pPr algn="ctr"/>
+            <a:endParaRPr/>
           </a:p>
         </p:txBody>
       </p:sp>
@@ -5715,7 +5737,7 @@
           <a:noFill/>
         </p:spPr>
         <p:txBody>
-          <a:bodyPr wrap="square" tIns="0" bIns="0" lIns="0" rIns="0">
+          <a:bodyPr wrap="square" lIns="0" tIns="0" rIns="0" bIns="0">
             <a:spAutoFit/>
           </a:bodyPr>
           <a:lstStyle/>
@@ -5750,7 +5772,7 @@
           <a:noFill/>
         </p:spPr>
         <p:txBody>
-          <a:bodyPr wrap="square" tIns="0" bIns="0" lIns="0" rIns="0">
+          <a:bodyPr wrap="square" lIns="0" tIns="0" rIns="0" bIns="0">
             <a:spAutoFit/>
           </a:bodyPr>
           <a:lstStyle/>
@@ -5785,7 +5807,7 @@
           <a:noFill/>
         </p:spPr>
         <p:txBody>
-          <a:bodyPr wrap="square" tIns="0" bIns="0" lIns="0" rIns="0">
+          <a:bodyPr wrap="square" lIns="0" tIns="0" rIns="0" bIns="0">
             <a:spAutoFit/>
           </a:bodyPr>
           <a:lstStyle/>
@@ -5820,7 +5842,7 @@
           <a:noFill/>
         </p:spPr>
         <p:txBody>
-          <a:bodyPr wrap="square" tIns="0" bIns="0" lIns="0" rIns="0">
+          <a:bodyPr wrap="square" lIns="0" tIns="0" rIns="0" bIns="0">
             <a:spAutoFit/>
           </a:bodyPr>
           <a:lstStyle/>
@@ -5880,6 +5902,7 @@
           <a:lstStyle/>
           <a:p>
             <a:pPr algn="ctr"/>
+            <a:endParaRPr/>
           </a:p>
         </p:txBody>
       </p:sp>
@@ -5923,6 +5946,7 @@
           <a:lstStyle/>
           <a:p>
             <a:pPr algn="ctr"/>
+            <a:endParaRPr/>
           </a:p>
         </p:txBody>
       </p:sp>
@@ -5943,7 +5967,7 @@
           <a:noFill/>
         </p:spPr>
         <p:txBody>
-          <a:bodyPr wrap="square" tIns="0" bIns="0" lIns="0" rIns="0">
+          <a:bodyPr wrap="square" lIns="0" tIns="0" rIns="0" bIns="0">
             <a:spAutoFit/>
           </a:bodyPr>
           <a:lstStyle/>
@@ -5978,7 +6002,7 @@
           <a:noFill/>
         </p:spPr>
         <p:txBody>
-          <a:bodyPr wrap="square" tIns="0" bIns="0" lIns="0" rIns="0">
+          <a:bodyPr wrap="square" lIns="0" tIns="0" rIns="0" bIns="0">
             <a:spAutoFit/>
           </a:bodyPr>
           <a:lstStyle/>
@@ -6013,7 +6037,7 @@
           <a:noFill/>
         </p:spPr>
         <p:txBody>
-          <a:bodyPr wrap="square" tIns="0" bIns="0" lIns="0" rIns="0">
+          <a:bodyPr wrap="square" lIns="0" tIns="0" rIns="0" bIns="0">
             <a:spAutoFit/>
           </a:bodyPr>
           <a:lstStyle/>
@@ -6048,7 +6072,7 @@
           <a:noFill/>
         </p:spPr>
         <p:txBody>
-          <a:bodyPr wrap="square" tIns="0" bIns="0" lIns="0" rIns="0">
+          <a:bodyPr wrap="square" lIns="0" tIns="0" rIns="0" bIns="0">
             <a:spAutoFit/>
           </a:bodyPr>
           <a:lstStyle/>
@@ -6083,7 +6107,7 @@
           <a:noFill/>
         </p:spPr>
         <p:txBody>
-          <a:bodyPr wrap="square" tIns="0" bIns="0" lIns="0" rIns="0">
+          <a:bodyPr wrap="square" lIns="0" tIns="0" rIns="0" bIns="0">
             <a:spAutoFit/>
           </a:bodyPr>
           <a:lstStyle/>
@@ -6143,6 +6167,7 @@
           <a:lstStyle/>
           <a:p>
             <a:pPr algn="ctr"/>
+            <a:endParaRPr/>
           </a:p>
         </p:txBody>
       </p:sp>
@@ -6186,6 +6211,7 @@
           <a:lstStyle/>
           <a:p>
             <a:pPr algn="ctr"/>
+            <a:endParaRPr/>
           </a:p>
         </p:txBody>
       </p:sp>
@@ -6206,7 +6232,7 @@
           <a:noFill/>
         </p:spPr>
         <p:txBody>
-          <a:bodyPr wrap="square" tIns="0" bIns="0" lIns="0" rIns="0">
+          <a:bodyPr wrap="square" lIns="0" tIns="0" rIns="0" bIns="0">
             <a:spAutoFit/>
           </a:bodyPr>
           <a:lstStyle/>
@@ -6241,7 +6267,7 @@
           <a:noFill/>
         </p:spPr>
         <p:txBody>
-          <a:bodyPr wrap="square" tIns="0" bIns="0" lIns="0" rIns="0">
+          <a:bodyPr wrap="square" lIns="0" tIns="0" rIns="0" bIns="0">
             <a:spAutoFit/>
           </a:bodyPr>
           <a:lstStyle/>
@@ -6276,7 +6302,7 @@
           <a:noFill/>
         </p:spPr>
         <p:txBody>
-          <a:bodyPr wrap="square" tIns="0" bIns="0" lIns="0" rIns="0">
+          <a:bodyPr wrap="square" lIns="0" tIns="0" rIns="0" bIns="0">
             <a:spAutoFit/>
           </a:bodyPr>
           <a:lstStyle/>
@@ -6336,6 +6362,7 @@
           <a:lstStyle/>
           <a:p>
             <a:pPr algn="ctr"/>
+            <a:endParaRPr/>
           </a:p>
         </p:txBody>
       </p:sp>
@@ -6379,6 +6406,7 @@
           <a:lstStyle/>
           <a:p>
             <a:pPr algn="ctr"/>
+            <a:endParaRPr/>
           </a:p>
         </p:txBody>
       </p:sp>
@@ -6399,7 +6427,7 @@
           <a:noFill/>
         </p:spPr>
         <p:txBody>
-          <a:bodyPr wrap="square" tIns="0" bIns="0" lIns="0" rIns="0">
+          <a:bodyPr wrap="square" lIns="0" tIns="0" rIns="0" bIns="0">
             <a:spAutoFit/>
           </a:bodyPr>
           <a:lstStyle/>
@@ -6434,7 +6462,7 @@
           <a:noFill/>
         </p:spPr>
         <p:txBody>
-          <a:bodyPr wrap="square" tIns="0" bIns="0" lIns="0" rIns="0">
+          <a:bodyPr wrap="square" lIns="0" tIns="0" rIns="0" bIns="0">
             <a:spAutoFit/>
           </a:bodyPr>
           <a:lstStyle/>
@@ -6469,7 +6497,7 @@
           <a:noFill/>
         </p:spPr>
         <p:txBody>
-          <a:bodyPr wrap="square" tIns="0" bIns="0" lIns="0" rIns="0">
+          <a:bodyPr wrap="square" lIns="0" tIns="0" rIns="0" bIns="0">
             <a:spAutoFit/>
           </a:bodyPr>
           <a:lstStyle/>
@@ -6504,7 +6532,7 @@
           <a:noFill/>
         </p:spPr>
         <p:txBody>
-          <a:bodyPr wrap="square" tIns="0" bIns="0" lIns="0" rIns="0">
+          <a:bodyPr wrap="square" lIns="0" tIns="0" rIns="0" bIns="0">
             <a:spAutoFit/>
           </a:bodyPr>
           <a:lstStyle/>
@@ -6539,7 +6567,7 @@
           <a:noFill/>
         </p:spPr>
         <p:txBody>
-          <a:bodyPr wrap="square" tIns="0" bIns="0" lIns="0" rIns="0">
+          <a:bodyPr wrap="square" lIns="0" tIns="0" rIns="0" bIns="0">
             <a:spAutoFit/>
           </a:bodyPr>
           <a:lstStyle/>
@@ -6574,7 +6602,7 @@
           <a:noFill/>
         </p:spPr>
         <p:txBody>
-          <a:bodyPr wrap="square" tIns="0" bIns="0" lIns="0" rIns="0">
+          <a:bodyPr wrap="square" lIns="0" tIns="0" rIns="0" bIns="0">
             <a:spAutoFit/>
           </a:bodyPr>
           <a:lstStyle/>
@@ -9111,7 +9139,7 @@
 </file>
 
 <file path=ppt/slides/slide14.xml><?xml version="1.0" encoding="utf-8"?>
-<p:sld xmlns:a="http://schemas.openxmlformats.org/drawingml/2006/main" xmlns:r="http://schemas.openxmlformats.org/officeDocument/2006/relationships" xmlns:p="http://schemas.openxmlformats.org/presentationml/2006/main">
+<p:sld xmlns:a="http://schemas.openxmlformats.org/drawingml/2006/main" xmlns:r="http://schemas.openxmlformats.org/officeDocument/2006/relationships" xmlns:p="http://schemas.openxmlformats.org/presentationml/2006/main" show="0">
   <p:cSld>
     <p:bg>
       <p:bgPr>

</xml_diff>